<commit_message>
Ajustes finais: correcao do Cosmos (sem TDAH/TEA nao verificado) + edicoes de capitalizacao do Gui
</commit_message>
<xml_diff>
--- a/Poliedro_Apresentacao_Completa.pptx
+++ b/Poliedro_Apresentacao_Completa.pptx
@@ -2699,7 +2699,7 @@
                 <a:ea typeface="Calibri" pitchFamily="34" charset="-122"/>
                 <a:cs typeface="Calibri" pitchFamily="34" charset="-120"/>
               </a:rPr>
-              <a:t>escolas Desafiantes (foco)</a:t>
+              <a:t>Escolas Desafiantes (foco)</a:t>
             </a:r>
             <a:endParaRPr lang="en-US" sz="1150" dirty="0"/>
           </a:p>
@@ -2777,7 +2777,7 @@
                 <a:ea typeface="Calibri" pitchFamily="34" charset="-122"/>
                 <a:cs typeface="Calibri" pitchFamily="34" charset="-120"/>
               </a:rPr>
-              <a:t>cidades prioritárias</a:t>
+              <a:t>Cidades Prioritárias</a:t>
             </a:r>
             <a:endParaRPr lang="en-US" sz="1150" dirty="0"/>
           </a:p>
@@ -18634,7 +18634,7 @@
       </p:sp>
       <p:pic>
         <p:nvPicPr>
-          <p:cNvPr id="4" name="Image 0" descr="data/outputs/funil_escolas.png">    </p:cNvPr>
+          <p:cNvPr id="4" name="Image 0" descr="/sessions/hopeful-gallant-maxwell/mnt/outputs/funil_escolas.png">    </p:cNvPr>
           <p:cNvPicPr>
             <a:picLocks noChangeAspect="1"/>
           </p:cNvPicPr>
@@ -18846,7 +18846,7 @@
       </p:sp>
       <p:pic>
         <p:nvPicPr>
-          <p:cNvPr id="4" name="Image 0" descr="data/outputs/segmentacao_comercial.png">    </p:cNvPr>
+          <p:cNvPr id="4" name="Image 0" descr="/sessions/hopeful-gallant-maxwell/mnt/outputs/segmentacao_comercial.png">    </p:cNvPr>
           <p:cNvPicPr>
             <a:picLocks noChangeAspect="1"/>
           </p:cNvPicPr>
@@ -20882,7 +20882,7 @@
                 <a:ea typeface="Calibri" pitchFamily="34" charset="-122"/>
                 <a:cs typeface="Calibri" pitchFamily="34" charset="-120"/>
               </a:rPr>
-              <a:t>Praças com vestibular próprio forte (SP: USP, Unicamp) podem ter escolas de elite subestimadas na média ENEM.</a:t>
+              <a:t>Praças com vestibular próprio forte (SP: USP, Unicamp, Unesp) podem ter escolas de elite subestimadas na média ENEM.</a:t>
             </a:r>
             <a:endParaRPr lang="en-US" sz="950" dirty="0"/>
           </a:p>
@@ -21626,7 +21626,7 @@
                 <a:ea typeface="Calibri" pitchFamily="34" charset="-122"/>
                 <a:cs typeface="Calibri" pitchFamily="34" charset="-120"/>
               </a:rPr>
-              <a:t>Em paralelo — não depende de validação, começa já: campanha de adesão ao Conviver e Integrar na safra de rematrícula (ago-set). No lado externo: selecionar ~15 “Desafiantes” em BH, Niterói e Vitória para piloto — confirmar manualmente o sistema de ensino atual antes de qualquer oferta.</a:t>
+              <a:t>Em paralelo: campanha de adesão ao Conviver e Integrar na safra de rematrícula (ago-set). Novos Negócios: selecionar ~15 “Desafiantes” em BH, Niterói e Vitória para piloto — confirmar manualmente o sistema de ensino atual antes de qualquer oferta.</a:t>
             </a:r>
             <a:endParaRPr lang="en-US" sz="1100" dirty="0"/>
           </a:p>
@@ -23809,7 +23809,7 @@
                 <a:ea typeface="Cambria" pitchFamily="34" charset="-122"/>
                 <a:cs typeface="Cambria" pitchFamily="34" charset="-120"/>
               </a:rPr>
-              <a:t>Cosmos + P+</a:t>
+              <a:t>Cosmos | P+</a:t>
             </a:r>
             <a:endParaRPr lang="en-US" sz="1500" dirty="0"/>
           </a:p>
@@ -24478,85 +24478,7 @@
       </p:sp>
       <p:sp>
         <p:nvSpPr>
-          <p:cNvPr id="4" name="Text 2"/>
-          <p:cNvSpPr/>
-          <p:nvPr/>
-        </p:nvSpPr>
-        <p:spPr>
-          <a:xfrm>
-            <a:off x="822960" y="2450592"/>
-            <a:ext cx="2743200" cy="274320"/>
-          </a:xfrm>
-          <a:prstGeom prst="rect">
-            <a:avLst/>
-          </a:prstGeom>
-          <a:noFill/>
-          <a:ln/>
-        </p:spPr>
-        <p:txBody>
-          <a:bodyPr wrap="square" rtlCol="0" anchor="ctr"/>
-          <a:lstStyle/>
-          <a:p>
-            <a:pPr indent="0" marL="0">
-              <a:buNone/>
-            </a:pPr>
-            <a:r>
-              <a:rPr lang="en-US" sz="1050" b="1" spc="100" kern="0" dirty="0">
-                <a:solidFill>
-                  <a:srgbClr val="D4AF37"/>
-                </a:solidFill>
-                <a:latin typeface="Calibri" pitchFamily="34" charset="0"/>
-                <a:ea typeface="Calibri" pitchFamily="34" charset="-122"/>
-                <a:cs typeface="Calibri" pitchFamily="34" charset="-120"/>
-              </a:rPr>
-              <a:t>SOM</a:t>
-            </a:r>
-            <a:endParaRPr lang="en-US" sz="1050" dirty="0"/>
-          </a:p>
-        </p:txBody>
-      </p:sp>
-      <p:sp>
-        <p:nvSpPr>
-          <p:cNvPr id="5" name="Text 3"/>
-          <p:cNvSpPr/>
-          <p:nvPr/>
-        </p:nvSpPr>
-        <p:spPr>
-          <a:xfrm>
-            <a:off x="9144000" y="2450592"/>
-            <a:ext cx="1828800" cy="274320"/>
-          </a:xfrm>
-          <a:prstGeom prst="rect">
-            <a:avLst/>
-          </a:prstGeom>
-          <a:noFill/>
-          <a:ln/>
-        </p:spPr>
-        <p:txBody>
-          <a:bodyPr wrap="square" rtlCol="0" anchor="ctr"/>
-          <a:lstStyle/>
-          <a:p>
-            <a:pPr algn="r" indent="0" marL="0">
-              <a:buNone/>
-            </a:pPr>
-            <a:r>
-              <a:rPr lang="en-US" sz="1050" spc="100" kern="0" dirty="0">
-                <a:solidFill>
-                  <a:srgbClr val="9AA7BD"/>
-                </a:solidFill>
-                <a:latin typeface="Calibri" pitchFamily="34" charset="0"/>
-                <a:ea typeface="Calibri" pitchFamily="34" charset="-122"/>
-                <a:cs typeface="Calibri" pitchFamily="34" charset="-120"/>
-              </a:rPr>
-              <a:t>TAM</a:t>
-            </a:r>
-            <a:endParaRPr lang="en-US" sz="1050" dirty="0"/>
-          </a:p>
-        </p:txBody>
-      </p:sp>
-      <p:sp>
-        <p:nvSpPr>
-          <p:cNvPr id="6" name="Shape 4"/>
+          <p:cNvPr id="4" name="Shape 2"/>
           <p:cNvSpPr/>
           <p:nvPr/>
         </p:nvSpPr>
@@ -24583,7 +24505,7 @@
       </p:sp>
       <p:sp>
         <p:nvSpPr>
-          <p:cNvPr id="7" name="Shape 5"/>
+          <p:cNvPr id="5" name="Shape 3"/>
           <p:cNvSpPr/>
           <p:nvPr/>
         </p:nvSpPr>
@@ -24605,7 +24527,7 @@
       </p:sp>
       <p:sp>
         <p:nvSpPr>
-          <p:cNvPr id="8" name="Text 6"/>
+          <p:cNvPr id="6" name="Text 4"/>
           <p:cNvSpPr/>
           <p:nvPr/>
         </p:nvSpPr>
@@ -24644,7 +24566,7 @@
       </p:sp>
       <p:sp>
         <p:nvSpPr>
-          <p:cNvPr id="9" name="Text 7"/>
+          <p:cNvPr id="7" name="Text 5"/>
           <p:cNvSpPr/>
           <p:nvPr/>
         </p:nvSpPr>
@@ -24683,7 +24605,7 @@
       </p:sp>
       <p:sp>
         <p:nvSpPr>
-          <p:cNvPr id="10" name="Text 8"/>
+          <p:cNvPr id="8" name="Text 6"/>
           <p:cNvSpPr/>
           <p:nvPr/>
         </p:nvSpPr>
@@ -24722,7 +24644,7 @@
       </p:sp>
       <p:sp>
         <p:nvSpPr>
-          <p:cNvPr id="11" name="Text 9"/>
+          <p:cNvPr id="9" name="Text 7"/>
           <p:cNvSpPr/>
           <p:nvPr/>
         </p:nvSpPr>
@@ -24761,7 +24683,7 @@
       </p:sp>
       <p:sp>
         <p:nvSpPr>
-          <p:cNvPr id="12" name="Text 10"/>
+          <p:cNvPr id="10" name="Text 8"/>
           <p:cNvSpPr/>
           <p:nvPr/>
         </p:nvSpPr>
@@ -24800,7 +24722,7 @@
       </p:sp>
       <p:sp>
         <p:nvSpPr>
-          <p:cNvPr id="13" name="Shape 11"/>
+          <p:cNvPr id="11" name="Shape 9"/>
           <p:cNvSpPr/>
           <p:nvPr/>
         </p:nvSpPr>
@@ -24827,7 +24749,7 @@
       </p:sp>
       <p:sp>
         <p:nvSpPr>
-          <p:cNvPr id="14" name="Text 12"/>
+          <p:cNvPr id="12" name="Text 10"/>
           <p:cNvSpPr/>
           <p:nvPr/>
         </p:nvSpPr>
@@ -24866,7 +24788,7 @@
       </p:sp>
       <p:sp>
         <p:nvSpPr>
-          <p:cNvPr id="15" name="Text 13"/>
+          <p:cNvPr id="13" name="Text 11"/>
           <p:cNvSpPr/>
           <p:nvPr/>
         </p:nvSpPr>
@@ -24897,7 +24819,7 @@
                 <a:ea typeface="Calibri" pitchFamily="34" charset="-122"/>
                 <a:cs typeface="Calibri" pitchFamily="34" charset="-120"/>
               </a:rPr>
-              <a:t>alunos na base (site institucional)</a:t>
+              <a:t>Alunos na base (site institucional)</a:t>
             </a:r>
             <a:endParaRPr lang="en-US" sz="1050" dirty="0"/>
           </a:p>
@@ -24905,7 +24827,7 @@
       </p:sp>
       <p:sp>
         <p:nvSpPr>
-          <p:cNvPr id="16" name="Shape 14"/>
+          <p:cNvPr id="14" name="Shape 12"/>
           <p:cNvSpPr/>
           <p:nvPr/>
         </p:nvSpPr>
@@ -24932,7 +24854,7 @@
       </p:sp>
       <p:sp>
         <p:nvSpPr>
-          <p:cNvPr id="17" name="Text 15"/>
+          <p:cNvPr id="15" name="Text 13"/>
           <p:cNvSpPr/>
           <p:nvPr/>
         </p:nvSpPr>
@@ -24971,7 +24893,7 @@
       </p:sp>
       <p:sp>
         <p:nvSpPr>
-          <p:cNvPr id="18" name="Text 16"/>
+          <p:cNvPr id="16" name="Text 14"/>
           <p:cNvSpPr/>
           <p:nvPr/>
         </p:nvSpPr>
@@ -25002,7 +24924,7 @@
                 <a:ea typeface="Calibri" pitchFamily="34" charset="-122"/>
                 <a:cs typeface="Calibri" pitchFamily="34" charset="-120"/>
               </a:rPr>
-              <a:t>ticket/aluno/ano cobrado pela concorrência (pesquisa própria)</a:t>
+              <a:t>Ticket/aluno/ano cobrado pela concorrência (pesquisa própria)</a:t>
             </a:r>
             <a:endParaRPr lang="en-US" sz="1050" dirty="0"/>
           </a:p>
@@ -25010,7 +24932,7 @@
       </p:sp>
       <p:sp>
         <p:nvSpPr>
-          <p:cNvPr id="19" name="Shape 17"/>
+          <p:cNvPr id="17" name="Shape 15"/>
           <p:cNvSpPr/>
           <p:nvPr/>
         </p:nvSpPr>
@@ -25037,7 +24959,7 @@
       </p:sp>
       <p:sp>
         <p:nvSpPr>
-          <p:cNvPr id="20" name="Text 18"/>
+          <p:cNvPr id="18" name="Text 16"/>
           <p:cNvSpPr/>
           <p:nvPr/>
         </p:nvSpPr>
@@ -25076,7 +24998,7 @@
       </p:sp>
       <p:sp>
         <p:nvSpPr>
-          <p:cNvPr id="21" name="Text 19"/>
+          <p:cNvPr id="19" name="Text 17"/>
           <p:cNvSpPr/>
           <p:nvPr/>
         </p:nvSpPr>
@@ -25107,7 +25029,7 @@
                 <a:ea typeface="Calibri" pitchFamily="34" charset="-122"/>
                 <a:cs typeface="Calibri" pitchFamily="34" charset="-120"/>
               </a:rPr>
-              <a:t>premissa de adesão de curto prazo usada no SOM</a:t>
+              <a:t>Premissa de adesão de curto prazo usada no SOM</a:t>
             </a:r>
             <a:endParaRPr lang="en-US" sz="1050" dirty="0"/>
           </a:p>
@@ -25115,7 +25037,7 @@
       </p:sp>
       <p:sp>
         <p:nvSpPr>
-          <p:cNvPr id="22" name="Text 20"/>
+          <p:cNvPr id="20" name="Text 18"/>
           <p:cNvSpPr/>
           <p:nvPr/>
         </p:nvSpPr>
@@ -25154,7 +25076,7 @@
       </p:sp>
       <p:sp>
         <p:nvSpPr>
-          <p:cNvPr id="23" name="Text 21"/>
+          <p:cNvPr id="21" name="Text 19"/>
           <p:cNvSpPr/>
           <p:nvPr/>
         </p:nvSpPr>
@@ -25193,7 +25115,7 @@
       </p:sp>
       <p:sp>
         <p:nvSpPr>
-          <p:cNvPr id="24" name="Text 22"/>
+          <p:cNvPr id="22" name="Text 20"/>
           <p:cNvSpPr/>
           <p:nvPr/>
         </p:nvSpPr>
@@ -25264,7 +25186,7 @@
       </p:grpSpPr>
       <p:pic>
         <p:nvPicPr>
-          <p:cNvPr id="2" name="Image 0" descr="data/outputs/cosmos_visual.png">    </p:cNvPr>
+          <p:cNvPr id="2" name="Image 0" descr="/sessions/hopeful-gallant-maxwell/mnt/outputs/cosmos_visual.png">    </p:cNvPr>
           <p:cNvPicPr>
             <a:picLocks noChangeAspect="1"/>
           </p:cNvPicPr>
@@ -25439,7 +25361,7 @@
                 <a:ea typeface="Calibri" pitchFamily="34" charset="-122"/>
                 <a:cs typeface="Calibri" pitchFamily="34" charset="-120"/>
               </a:rPr>
-              <a:t>Cosmos é o hub de IA integrado ao P+, a ferramenta de diagnóstico pedagógico da Poliedro: identifica dificuldades por turma e aluno, e apoia o professor na adaptação de atividades para alunos com TDAH, TEA e demais perfis de inclusão — aliviando o que hoje é uma das maiores fontes de sobrecarga do educador na escola particular.</a:t>
+              <a:t>Cosmos é o hub de IA integrado ao P+ (avaliar, personalizar, planejar, analisar): identifica desempenho por turma e aluno, e apoia o professor personalizando estratégias de ensino para as necessidades específicas de cada estudante — incluindo perfis de inclusão — aliviando o que hoje é uma das maiores fontes de sobrecarga do educador na escola particular.</a:t>
             </a:r>
             <a:endParaRPr lang="en-US" sz="1250" dirty="0"/>
           </a:p>
@@ -27835,7 +27757,7 @@
       </p:sp>
       <p:pic>
         <p:nvPicPr>
-          <p:cNvPr id="3" name="Image 0" descr="data/outputs/grafico_top10_cidades_dark.png">    </p:cNvPr>
+          <p:cNvPr id="3" name="Image 0" descr="/sessions/hopeful-gallant-maxwell/mnt/outputs/grafico_top10_cidades_dark.png">    </p:cNvPr>
           <p:cNvPicPr>
             <a:picLocks noChangeAspect="1"/>
           </p:cNvPicPr>
@@ -28008,7 +27930,7 @@
       </p:sp>
       <p:pic>
         <p:nvPicPr>
-          <p:cNvPr id="3" name="Image 0" descr="data/outputs/grafico_dispersao_cidades_dark.png">    </p:cNvPr>
+          <p:cNvPr id="3" name="Image 0" descr="/sessions/hopeful-gallant-maxwell/mnt/outputs/grafico_dispersao_cidades_dark.png">    </p:cNvPr>
           <p:cNvPicPr>
             <a:picLocks noChangeAspect="1"/>
           </p:cNvPicPr>

</xml_diff>